<commit_message>
docs: update deck for local Terraform (plan/apply/destroy on minikube)
</commit_message>
<xml_diff>
--- a/presentation/GearLoop-Capstone.pptx
+++ b/presentation/GearLoop-Capstone.pptx
@@ -125,44 +125,44 @@
   <p:extLst>
     <p:ext uri="{521415D9-36F7-43E2-AB2F-B90AF26B5E84}">
       <p14:sectionLst xmlns:p14="http://schemas.microsoft.com/office/powerpoint/2010/main">
-        <p14:section name="Introduction" id="{f77372ba-fd7f-2b42-089c-b350765bafa6}">
+        <p14:section name="Introduction" id="{7d10cc29-a68f-8f9c-1c7e-557a60ad242a}">
           <p14:sldIdLst>
             <p14:sldId id="256"/>
             <p14:sldId id="257"/>
           </p14:sldIdLst>
         </p14:section>
-        <p14:section name="Architecture" id="{e916e99a-7d0c-f9cc-455c-9ef689f8cbae}">
+        <p14:section name="Architecture" id="{c7e29be8-7d27-4978-9690-ee1e9bc3e117}">
           <p14:sldIdLst>
             <p14:sldId id="258"/>
           </p14:sldIdLst>
         </p14:section>
-        <p14:section name="Application" id="{eeaba746-b0ee-9fce-48c0-f687b35df584}">
+        <p14:section name="Application" id="{31d3a430-385d-af87-06cb-b67a291dc646}">
           <p14:sldIdLst>
             <p14:sldId id="259"/>
             <p14:sldId id="260"/>
             <p14:sldId id="261"/>
           </p14:sldIdLst>
         </p14:section>
-        <p14:section name="Build and test" id="{7e1061ec-193d-fec7-8ffc-2ea74e12694e}">
+        <p14:section name="Build and test" id="{843ef060-94b3-19da-809e-637a49631b0c}">
           <p14:sldIdLst>
             <p14:sldId id="262"/>
             <p14:sldId id="263"/>
           </p14:sldIdLst>
         </p14:section>
-        <p14:section name="Delivery" id="{14b8efb5-08cc-4cfd-04fe-9dc500eda1e2}">
+        <p14:section name="Delivery" id="{794ac28f-c567-8782-9b17-98965fa9bde5}">
           <p14:sldIdLst>
             <p14:sldId id="264"/>
             <p14:sldId id="265"/>
           </p14:sldIdLst>
         </p14:section>
-        <p14:section name="Infrastructure" id="{cca850d4-003b-7a7c-0c08-70cc03f1a724}">
+        <p14:section name="Infrastructure" id="{e8240235-eb07-31b6-be2e-18cf103ef7af}">
           <p14:sldIdLst>
             <p14:sldId id="266"/>
             <p14:sldId id="267"/>
             <p14:sldId id="268"/>
           </p14:sldIdLst>
         </p14:section>
-        <p14:section name="Operate" id="{c0687a7a-5e90-29dc-bbc8-24bac305201e}">
+        <p14:section name="Operate" id="{66cb701a-96cc-3b52-4c39-aee8ecf955b0}">
           <p14:sldIdLst>
             <p14:sldId id="269"/>
             <p14:sldId id="270"/>
@@ -170,7 +170,7 @@
             <p14:sldId id="272"/>
           </p14:sldIdLst>
         </p14:section>
-        <p14:section name="Wrap-up" id="{51a8a777-f8af-764c-90f0-f428e91977bb}">
+        <p14:section name="Wrap-up" id="{4b5606fd-492f-68c5-e271-4a4c8b7cf305}">
           <p14:sldIdLst>
             <p14:sldId id="273"/>
             <p14:sldId id="274"/>
@@ -1500,7 +1500,7 @@
           <a:p>
             <a:r>
               <a:rPr lang="en-US" dirty="0"/>
-              <a:t>Two public subnets for load balancers, two private subnets for the worker nodes, one NAT gateway to keep cost down, and the EKS cluster with the add-ons the app actually needs: metrics-server for the HPA, and the EBS CSI driver so the Postgres volume can bind. Be clear in the demo: validate passes, but plan and apply still need AWS credentials.</a:t>
+              <a:t>AWS is out of scope for this project, so Terraform manages the local cluster instead of creating one in the cloud. It owns both namespaces, the quota and limit range, and the two Helm releases, in dependency order: monitoring first because the app chart needs its CRDs. I ran plan, apply, destroy and apply again. Because Terraform owns the namespaces, destroy also removes the things Helm keeps on uninstall, like the database Secret and the Postgres volume.</a:t>
             </a:r>
             <a:endParaRPr lang="en-US" dirty="0"/>
           </a:p>
@@ -2116,7 +2116,7 @@
           <a:p>
             <a:r>
               <a:rPr lang="en-US" dirty="0"/>
-              <a:t>Being explicit about status. Everything above the line was run and screenshotted. The two remaining items need things outside this laptop: a GitHub push for the pipeline, and AWS credentials for Terraform.</a:t>
+              <a:t>Being explicit about status. Everything marked Done was run and screenshotted. The one remaining item needs something outside this laptop: a push to GitHub so the pipeline can run.</a:t>
             </a:r>
             <a:endParaRPr lang="en-US" dirty="0"/>
           </a:p>
@@ -2204,7 +2204,7 @@
           <a:p>
             <a:r>
               <a:rPr lang="en-US" dirty="0"/>
-              <a:t>Demo order follows the rubric: application, commit, pipeline, image, scan, registry, infrastructure, Kubernetes, Helm, Ingress, autoscaling, monitoring, troubleshooting.</a:t>
+              <a:t>Demo order follows the rubric: application, commit, pipeline, image, scan, registry, Terraform, Kubernetes, Helm, Ingress, autoscaling, monitoring, troubleshooting.</a:t>
             </a:r>
             <a:endParaRPr lang="en-US" dirty="0"/>
           </a:p>
@@ -2380,7 +2380,7 @@
           <a:p>
             <a:r>
               <a:rPr lang="en-US" dirty="0"/>
-              <a:t>Top row is the delivery path: a push runs the pipeline, which tests, builds and scans both images and pushes them to GHCR tagged with the commit SHA. Helm deploys that exact SHA. Terraform creates the AWS network and EKS cluster. Inside the cluster the browser only ever talks to the Ingress, and Prometheus scrapes the backend.</a:t>
+              <a:t>Top row is the delivery path: a push runs the pipeline, which tests, builds and scans both images and pushes them to GHCR tagged with the commit SHA. Helm deploys that exact SHA. Terraform declares what runs on the cluster: the namespaces, quota, the monitoring stack and the app release. Inside the cluster the browser only ever talks to the Ingress, and Prometheus scrapes the backend.</a:t>
             </a:r>
             <a:endParaRPr lang="en-US" dirty="0"/>
           </a:p>
@@ -3774,7 +3774,7 @@
                   <a:schemeClr val="accent6"/>
                 </a:solidFill>
               </a:rPr>
-              <a:t>React · FastAPI · PostgreSQL · Docker · GitHub Actions · Trivy · GHCR · Terraform · EKS · Helm · Ingress · HPA · Prometheus · Grafana</a:t>
+              <a:t>React · FastAPI · PostgreSQL · Docker · GitHub Actions · Trivy · GHCR · Terraform · Kubernetes · Helm · Ingress · HPA · Prometheus · Grafana</a:t>
             </a:r>
             <a:endParaRPr lang="en-US" sz="1200" dirty="0"/>
           </a:p>
@@ -4245,7 +4245,7 @@
                   <a:schemeClr val="tx1"/>
                 </a:solidFill>
               </a:rPr>
-              <a:t>Terraform: AWS VPC + EKS as code</a:t>
+              <a:t>Terraform: the cluster setup as code</a:t>
             </a:r>
             <a:endParaRPr lang="en-US" sz="3400" dirty="0"/>
           </a:p>
@@ -4253,26 +4253,62 @@
       </p:sp>
       <p:sp>
         <p:nvSpPr>
-          <p:cNvPr id="3" name="vpc"/>
+          <p:cNvPr id="3" name="Text 1"/>
+          <p:cNvSpPr txBox="1"/>
+          <p:nvPr/>
+        </p:nvSpPr>
+        <p:spPr>
+          <a:xfrm>
+            <a:off x="548640" y="1325880"/>
+            <a:ext cx="5394960" cy="685800"/>
+          </a:xfrm>
+          <a:prstGeom prst="rect">
+            <a:avLst/>
+          </a:prstGeom>
+          <a:noFill/>
+          <a:ln/>
+        </p:spPr>
+        <p:txBody>
+          <a:bodyPr wrap="square" lIns="0" tIns="0" rIns="0" bIns="0" rtlCol="0" anchor="t"/>
+          <a:lstStyle/>
+          <a:p>
+            <a:pPr indent="0" marL="0">
+              <a:buNone/>
+            </a:pPr>
+            <a:r>
+              <a:rPr lang="en-US" sz="1400" dirty="0">
+                <a:solidFill>
+                  <a:schemeClr val="tx2"/>
+                </a:solidFill>
+              </a:rPr>
+              <a:t>No cloud account needed: the kubernetes and helm providers manage the local cluster, so plan, apply and destroy really run.</a:t>
+            </a:r>
+            <a:endParaRPr lang="en-US" sz="1400" dirty="0"/>
+          </a:p>
+        </p:txBody>
+      </p:sp>
+      <p:sp>
+        <p:nvSpPr>
+          <p:cNvPr id="4" name="box-kubernetes_namespace_v1"/>
           <p:cNvSpPr/>
           <p:nvPr/>
         </p:nvSpPr>
         <p:spPr>
           <a:xfrm>
-            <a:off x="548640" y="1371600"/>
-            <a:ext cx="6675120" cy="4846320"/>
+            <a:off x="548640" y="2148840"/>
+            <a:ext cx="5394960" cy="640080"/>
           </a:xfrm>
           <a:prstGeom prst="roundRect">
             <a:avLst>
-              <a:gd name="adj" fmla="val 1887"/>
+              <a:gd name="adj" fmla="val 11429"/>
             </a:avLst>
           </a:prstGeom>
           <a:solidFill>
-            <a:schemeClr val="bg1"/>
+            <a:schemeClr val="bg2"/>
           </a:solidFill>
-          <a:ln w="19050">
+          <a:ln w="12700">
             <a:solidFill>
-              <a:schemeClr val="accent1"/>
+              <a:schemeClr val="bg2"/>
             </a:solidFill>
             <a:prstDash val="solid"/>
           </a:ln>
@@ -4280,14 +4316,14 @@
       </p:sp>
       <p:sp>
         <p:nvSpPr>
-          <p:cNvPr id="4" name="Text 2"/>
+          <p:cNvPr id="5" name="Text 3"/>
           <p:cNvSpPr txBox="1"/>
           <p:nvPr/>
         </p:nvSpPr>
         <p:spPr>
           <a:xfrm>
-            <a:off x="731520" y="1463040"/>
-            <a:ext cx="3657600" cy="274320"/>
+            <a:off x="548640" y="2148840"/>
+            <a:ext cx="5394960" cy="640080"/>
           </a:xfrm>
           <a:prstGeom prst="rect">
             <a:avLst/>
@@ -4296,38 +4332,278 @@
           <a:ln/>
         </p:spPr>
         <p:txBody>
-          <a:bodyPr wrap="square" lIns="0" tIns="0" rIns="0" bIns="0" rtlCol="0" anchor="t"/>
-          <a:lstStyle/>
-          <a:p>
-            <a:pPr indent="0" marL="0">
-              <a:buNone/>
-            </a:pPr>
-            <a:r>
-              <a:rPr lang="en-US" sz="1200" b="1" dirty="0">
-                <a:solidFill>
-                  <a:schemeClr val="accent1"/>
-                </a:solidFill>
-              </a:rPr>
-              <a:t>VPC 10.42.0.0/16  ·  ap-south-1</a:t>
-            </a:r>
-            <a:endParaRPr lang="en-US" sz="1200" dirty="0"/>
-          </a:p>
-        </p:txBody>
-      </p:sp>
-      <p:sp>
-        <p:nvSpPr>
-          <p:cNvPr id="5" name="box-Internet Gateway"/>
+          <a:bodyPr wrap="square" lIns="635" tIns="635" rIns="635" bIns="635" rtlCol="0" anchor="ctr"/>
+          <a:lstStyle/>
+          <a:p>
+            <a:pPr algn="ctr" indent="0" marL="0">
+              <a:buNone/>
+            </a:pPr>
+            <a:r>
+              <a:rPr lang="en-US" sz="1400" b="1" dirty="0">
+                <a:solidFill>
+                  <a:schemeClr val="tx1"/>
+                </a:solidFill>
+              </a:rPr>
+              <a:t>kubernetes_namespace_v1</a:t>
+            </a:r>
+            <a:endParaRPr lang="en-US" sz="1400" dirty="0"/>
+          </a:p>
+          <a:p>
+            <a:pPr algn="ctr" indent="0" marL="0">
+              <a:buNone/>
+            </a:pPr>
+            <a:r>
+              <a:rPr lang="en-US" sz="1200" dirty="0">
+                <a:solidFill>
+                  <a:schemeClr val="tx2"/>
+                </a:solidFill>
+              </a:rPr>
+              <a:t>gearloop (PSA restricted) + monitoring</a:t>
+            </a:r>
+            <a:endParaRPr lang="en-US" sz="1400" dirty="0"/>
+          </a:p>
+        </p:txBody>
+      </p:sp>
+      <p:sp>
+        <p:nvSpPr>
+          <p:cNvPr id="6" name="arrow"/>
           <p:cNvSpPr/>
           <p:nvPr/>
         </p:nvSpPr>
         <p:spPr>
           <a:xfrm>
-            <a:off x="5394960" y="1444752"/>
-            <a:ext cx="1645920" cy="365760"/>
+            <a:off x="3246120" y="2788920"/>
+            <a:ext cx="914" cy="228600"/>
+          </a:xfrm>
+          <a:prstGeom prst="line">
+            <a:avLst/>
+          </a:prstGeom>
+          <a:noFill/>
+          <a:ln w="19050">
+            <a:solidFill>
+              <a:srgbClr val="8A7F73"/>
+            </a:solidFill>
+            <a:prstDash val="solid"/>
+            <a:tailEnd type="triangle"/>
+          </a:ln>
+        </p:spPr>
+      </p:sp>
+      <p:sp>
+        <p:nvSpPr>
+          <p:cNvPr id="7" name="box-quota + limit range"/>
+          <p:cNvSpPr/>
+          <p:nvPr/>
+        </p:nvSpPr>
+        <p:spPr>
+          <a:xfrm>
+            <a:off x="548640" y="3017520"/>
+            <a:ext cx="5394960" cy="640080"/>
           </a:xfrm>
           <a:prstGeom prst="roundRect">
             <a:avLst>
-              <a:gd name="adj" fmla="val 20000"/>
+              <a:gd name="adj" fmla="val 11429"/>
+            </a:avLst>
+          </a:prstGeom>
+          <a:solidFill>
+            <a:schemeClr val="bg2"/>
+          </a:solidFill>
+          <a:ln w="12700">
+            <a:solidFill>
+              <a:schemeClr val="bg2"/>
+            </a:solidFill>
+            <a:prstDash val="solid"/>
+          </a:ln>
+        </p:spPr>
+      </p:sp>
+      <p:sp>
+        <p:nvSpPr>
+          <p:cNvPr id="8" name="Text 6"/>
+          <p:cNvSpPr txBox="1"/>
+          <p:nvPr/>
+        </p:nvSpPr>
+        <p:spPr>
+          <a:xfrm>
+            <a:off x="548640" y="3017520"/>
+            <a:ext cx="5394960" cy="640080"/>
+          </a:xfrm>
+          <a:prstGeom prst="rect">
+            <a:avLst/>
+          </a:prstGeom>
+          <a:noFill/>
+          <a:ln/>
+        </p:spPr>
+        <p:txBody>
+          <a:bodyPr wrap="square" lIns="635" tIns="635" rIns="635" bIns="635" rtlCol="0" anchor="ctr"/>
+          <a:lstStyle/>
+          <a:p>
+            <a:pPr algn="ctr" indent="0" marL="0">
+              <a:buNone/>
+            </a:pPr>
+            <a:r>
+              <a:rPr lang="en-US" sz="1400" b="1" dirty="0">
+                <a:solidFill>
+                  <a:schemeClr val="tx1"/>
+                </a:solidFill>
+              </a:rPr>
+              <a:t>quota + limit range</a:t>
+            </a:r>
+            <a:endParaRPr lang="en-US" sz="1400" dirty="0"/>
+          </a:p>
+          <a:p>
+            <a:pPr algn="ctr" indent="0" marL="0">
+              <a:buNone/>
+            </a:pPr>
+            <a:r>
+              <a:rPr lang="en-US" sz="1200" dirty="0">
+                <a:solidFill>
+                  <a:schemeClr val="tx2"/>
+                </a:solidFill>
+              </a:rPr>
+              <a:t>caps what the namespace can request</a:t>
+            </a:r>
+            <a:endParaRPr lang="en-US" sz="1400" dirty="0"/>
+          </a:p>
+        </p:txBody>
+      </p:sp>
+      <p:sp>
+        <p:nvSpPr>
+          <p:cNvPr id="9" name="arrow"/>
+          <p:cNvSpPr/>
+          <p:nvPr/>
+        </p:nvSpPr>
+        <p:spPr>
+          <a:xfrm>
+            <a:off x="3246120" y="3657600"/>
+            <a:ext cx="914" cy="228600"/>
+          </a:xfrm>
+          <a:prstGeom prst="line">
+            <a:avLst/>
+          </a:prstGeom>
+          <a:noFill/>
+          <a:ln w="19050">
+            <a:solidFill>
+              <a:srgbClr val="8A7F73"/>
+            </a:solidFill>
+            <a:prstDash val="solid"/>
+            <a:tailEnd type="triangle"/>
+          </a:ln>
+        </p:spPr>
+      </p:sp>
+      <p:sp>
+        <p:nvSpPr>
+          <p:cNvPr id="10" name="box-helm_release.monitoring"/>
+          <p:cNvSpPr/>
+          <p:nvPr/>
+        </p:nvSpPr>
+        <p:spPr>
+          <a:xfrm>
+            <a:off x="548640" y="3886200"/>
+            <a:ext cx="5394960" cy="640080"/>
+          </a:xfrm>
+          <a:prstGeom prst="roundRect">
+            <a:avLst>
+              <a:gd name="adj" fmla="val 11429"/>
+            </a:avLst>
+          </a:prstGeom>
+          <a:solidFill>
+            <a:schemeClr val="bg2"/>
+          </a:solidFill>
+          <a:ln w="12700">
+            <a:solidFill>
+              <a:schemeClr val="bg2"/>
+            </a:solidFill>
+            <a:prstDash val="solid"/>
+          </a:ln>
+        </p:spPr>
+      </p:sp>
+      <p:sp>
+        <p:nvSpPr>
+          <p:cNvPr id="11" name="Text 9"/>
+          <p:cNvSpPr txBox="1"/>
+          <p:nvPr/>
+        </p:nvSpPr>
+        <p:spPr>
+          <a:xfrm>
+            <a:off x="548640" y="3886200"/>
+            <a:ext cx="5394960" cy="640080"/>
+          </a:xfrm>
+          <a:prstGeom prst="rect">
+            <a:avLst/>
+          </a:prstGeom>
+          <a:noFill/>
+          <a:ln/>
+        </p:spPr>
+        <p:txBody>
+          <a:bodyPr wrap="square" lIns="635" tIns="635" rIns="635" bIns="635" rtlCol="0" anchor="ctr"/>
+          <a:lstStyle/>
+          <a:p>
+            <a:pPr algn="ctr" indent="0" marL="0">
+              <a:buNone/>
+            </a:pPr>
+            <a:r>
+              <a:rPr lang="en-US" sz="1400" b="1" dirty="0">
+                <a:solidFill>
+                  <a:schemeClr val="tx1"/>
+                </a:solidFill>
+              </a:rPr>
+              <a:t>helm_release.monitoring</a:t>
+            </a:r>
+            <a:endParaRPr lang="en-US" sz="1400" dirty="0"/>
+          </a:p>
+          <a:p>
+            <a:pPr algn="ctr" indent="0" marL="0">
+              <a:buNone/>
+            </a:pPr>
+            <a:r>
+              <a:rPr lang="en-US" sz="1200" dirty="0">
+                <a:solidFill>
+                  <a:schemeClr val="tx2"/>
+                </a:solidFill>
+              </a:rPr>
+              <a:t>kube-prometheus-stack 92.9.0 (CRDs first)</a:t>
+            </a:r>
+            <a:endParaRPr lang="en-US" sz="1400" dirty="0"/>
+          </a:p>
+        </p:txBody>
+      </p:sp>
+      <p:sp>
+        <p:nvSpPr>
+          <p:cNvPr id="12" name="arrow"/>
+          <p:cNvSpPr/>
+          <p:nvPr/>
+        </p:nvSpPr>
+        <p:spPr>
+          <a:xfrm>
+            <a:off x="3246120" y="4526280"/>
+            <a:ext cx="914" cy="228600"/>
+          </a:xfrm>
+          <a:prstGeom prst="line">
+            <a:avLst/>
+          </a:prstGeom>
+          <a:noFill/>
+          <a:ln w="19050">
+            <a:solidFill>
+              <a:srgbClr val="8A7F73"/>
+            </a:solidFill>
+            <a:prstDash val="solid"/>
+            <a:tailEnd type="triangle"/>
+          </a:ln>
+        </p:spPr>
+      </p:sp>
+      <p:sp>
+        <p:nvSpPr>
+          <p:cNvPr id="13" name="box-helm_release.gearloop"/>
+          <p:cNvSpPr/>
+          <p:nvPr/>
+        </p:nvSpPr>
+        <p:spPr>
+          <a:xfrm>
+            <a:off x="548640" y="4754880"/>
+            <a:ext cx="5394960" cy="640080"/>
+          </a:xfrm>
+          <a:prstGeom prst="roundRect">
+            <a:avLst>
+              <a:gd name="adj" fmla="val 11429"/>
             </a:avLst>
           </a:prstGeom>
           <a:solidFill>
@@ -4343,14 +4619,14 @@
       </p:sp>
       <p:sp>
         <p:nvSpPr>
-          <p:cNvPr id="6" name="Text 4"/>
+          <p:cNvPr id="14" name="Text 12"/>
           <p:cNvSpPr txBox="1"/>
           <p:nvPr/>
         </p:nvSpPr>
         <p:spPr>
           <a:xfrm>
-            <a:off x="5394960" y="1444752"/>
-            <a:ext cx="1645920" cy="365760"/>
+            <a:off x="548640" y="4754880"/>
+            <a:ext cx="5394960" cy="640080"/>
           </a:xfrm>
           <a:prstGeom prst="rect">
             <a:avLst/>
@@ -4366,27 +4642,41 @@
               <a:buNone/>
             </a:pPr>
             <a:r>
-              <a:rPr lang="en-US" sz="1100" b="1" dirty="0">
+              <a:rPr lang="en-US" sz="1400" b="1" dirty="0">
                 <a:solidFill>
                   <a:schemeClr val="bg1"/>
                 </a:solidFill>
               </a:rPr>
-              <a:t>Internet Gateway</a:t>
-            </a:r>
-            <a:endParaRPr lang="en-US" sz="1100" dirty="0"/>
-          </a:p>
-        </p:txBody>
-      </p:sp>
-      <p:sp>
-        <p:nvSpPr>
-          <p:cNvPr id="7" name="Text 5"/>
+              <a:t>helm_release.gearloop</a:t>
+            </a:r>
+            <a:endParaRPr lang="en-US" sz="1400" dirty="0"/>
+          </a:p>
+          <a:p>
+            <a:pPr algn="ctr" indent="0" marL="0">
+              <a:buNone/>
+            </a:pPr>
+            <a:r>
+              <a:rPr lang="en-US" sz="1200" dirty="0">
+                <a:solidFill>
+                  <a:schemeClr val="bg2"/>
+                </a:solidFill>
+              </a:rPr>
+              <a:t>../helm/gearloop · atomic, waits for Ready</a:t>
+            </a:r>
+            <a:endParaRPr lang="en-US" sz="1400" dirty="0"/>
+          </a:p>
+        </p:txBody>
+      </p:sp>
+      <p:sp>
+        <p:nvSpPr>
+          <p:cNvPr id="15" name="Text 13"/>
           <p:cNvSpPr txBox="1"/>
           <p:nvPr/>
         </p:nvSpPr>
         <p:spPr>
           <a:xfrm>
-            <a:off x="777240" y="1874520"/>
-            <a:ext cx="2926080" cy="274320"/>
+            <a:off x="548640" y="5486400"/>
+            <a:ext cx="1737360" cy="502920"/>
           </a:xfrm>
           <a:prstGeom prst="rect">
             <a:avLst/>
@@ -4402,54 +4692,27 @@
               <a:buNone/>
             </a:pPr>
             <a:r>
-              <a:rPr lang="en-US" sz="1100" b="1" dirty="0">
-                <a:solidFill>
-                  <a:schemeClr val="accent6"/>
-                </a:solidFill>
-              </a:rPr>
-              <a:t>AZ ap-south-1a</a:t>
-            </a:r>
-            <a:endParaRPr lang="en-US" sz="1100" dirty="0"/>
-          </a:p>
-        </p:txBody>
-      </p:sp>
-      <p:sp>
-        <p:nvSpPr>
-          <p:cNvPr id="8" name="box-Public subnet a"/>
-          <p:cNvSpPr/>
-          <p:nvPr/>
-        </p:nvSpPr>
-        <p:spPr>
-          <a:xfrm>
-            <a:off x="777240" y="2194560"/>
-            <a:ext cx="2926080" cy="960120"/>
-          </a:xfrm>
-          <a:prstGeom prst="roundRect">
-            <a:avLst>
-              <a:gd name="adj" fmla="val 7619"/>
-            </a:avLst>
-          </a:prstGeom>
-          <a:solidFill>
-            <a:srgbClr val="E8F1EA"/>
-          </a:solidFill>
-          <a:ln w="12700">
-            <a:solidFill>
-              <a:srgbClr val="E8F1EA"/>
-            </a:solidFill>
-            <a:prstDash val="solid"/>
-          </a:ln>
-        </p:spPr>
-      </p:sp>
-      <p:sp>
-        <p:nvSpPr>
-          <p:cNvPr id="9" name="Text 7"/>
+              <a:rPr lang="en-US" sz="2800" b="1" dirty="0">
+                <a:solidFill>
+                  <a:schemeClr val="accent1"/>
+                </a:solidFill>
+              </a:rPr>
+              <a:t>6</a:t>
+            </a:r>
+            <a:endParaRPr lang="en-US" sz="2800" dirty="0"/>
+          </a:p>
+        </p:txBody>
+      </p:sp>
+      <p:sp>
+        <p:nvSpPr>
+          <p:cNvPr id="16" name="Text 14"/>
           <p:cNvSpPr txBox="1"/>
           <p:nvPr/>
         </p:nvSpPr>
         <p:spPr>
           <a:xfrm>
-            <a:off x="777240" y="2194560"/>
-            <a:ext cx="2926080" cy="960120"/>
+            <a:off x="548640" y="5989320"/>
+            <a:ext cx="1737360" cy="274320"/>
           </a:xfrm>
           <a:prstGeom prst="rect">
             <a:avLst/>
@@ -4458,75 +4721,34 @@
           <a:ln/>
         </p:spPr>
         <p:txBody>
-          <a:bodyPr wrap="square" lIns="635" tIns="635" rIns="635" bIns="635" rtlCol="0" anchor="ctr"/>
-          <a:lstStyle/>
-          <a:p>
-            <a:pPr algn="ctr" indent="0" marL="0">
-              <a:buNone/>
-            </a:pPr>
-            <a:r>
-              <a:rPr lang="en-US" sz="1400" b="1" dirty="0">
-                <a:solidFill>
-                  <a:schemeClr val="tx1"/>
-                </a:solidFill>
-              </a:rPr>
-              <a:t>Public subnet a</a:t>
-            </a:r>
-            <a:endParaRPr lang="en-US" sz="1400" dirty="0"/>
-          </a:p>
-          <a:p>
-            <a:pPr algn="ctr" indent="0" marL="0">
-              <a:buNone/>
-            </a:pPr>
-            <a:r>
-              <a:rPr lang="en-US" sz="1100" dirty="0">
+          <a:bodyPr wrap="square" lIns="0" tIns="0" rIns="0" bIns="0" rtlCol="0" anchor="t"/>
+          <a:lstStyle/>
+          <a:p>
+            <a:pPr indent="0" marL="0">
+              <a:buNone/>
+            </a:pPr>
+            <a:r>
+              <a:rPr lang="en-US" sz="1200" dirty="0">
                 <a:solidFill>
                   <a:schemeClr val="tx2"/>
                 </a:solidFill>
               </a:rPr>
-              <a:t>load balancers · NAT gateway</a:t>
-            </a:r>
-            <a:endParaRPr lang="en-US" sz="1400" dirty="0"/>
-          </a:p>
-        </p:txBody>
-      </p:sp>
-      <p:sp>
-        <p:nvSpPr>
-          <p:cNvPr id="10" name="box-Private subnet a"/>
-          <p:cNvSpPr/>
-          <p:nvPr/>
-        </p:nvSpPr>
-        <p:spPr>
-          <a:xfrm>
-            <a:off x="777240" y="3337560"/>
-            <a:ext cx="2926080" cy="1234440"/>
-          </a:xfrm>
-          <a:prstGeom prst="roundRect">
-            <a:avLst>
-              <a:gd name="adj" fmla="val 5926"/>
-            </a:avLst>
-          </a:prstGeom>
-          <a:solidFill>
-            <a:srgbClr val="EEF0F5"/>
-          </a:solidFill>
-          <a:ln w="12700">
-            <a:solidFill>
-              <a:srgbClr val="EEF0F5"/>
-            </a:solidFill>
-            <a:prstDash val="solid"/>
-          </a:ln>
-        </p:spPr>
-      </p:sp>
-      <p:sp>
-        <p:nvSpPr>
-          <p:cNvPr id="11" name="Text 9"/>
+              <a:t>resources</a:t>
+            </a:r>
+            <a:endParaRPr lang="en-US" sz="1200" dirty="0"/>
+          </a:p>
+        </p:txBody>
+      </p:sp>
+      <p:sp>
+        <p:nvSpPr>
+          <p:cNvPr id="17" name="Text 15"/>
           <p:cNvSpPr txBox="1"/>
           <p:nvPr/>
         </p:nvSpPr>
         <p:spPr>
           <a:xfrm>
-            <a:off x="777240" y="3337560"/>
-            <a:ext cx="2926080" cy="1234440"/>
+            <a:off x="2377440" y="5486400"/>
+            <a:ext cx="1737360" cy="502920"/>
           </a:xfrm>
           <a:prstGeom prst="rect">
             <a:avLst/>
@@ -4535,62 +4757,34 @@
           <a:ln/>
         </p:spPr>
         <p:txBody>
-          <a:bodyPr wrap="square" lIns="635" tIns="635" rIns="635" bIns="635" rtlCol="0" anchor="ctr"/>
-          <a:lstStyle/>
-          <a:p>
-            <a:pPr algn="ctr" indent="0" marL="0">
-              <a:buNone/>
-            </a:pPr>
-            <a:r>
-              <a:rPr lang="en-US" sz="1400" b="1" dirty="0">
-                <a:solidFill>
-                  <a:schemeClr val="tx1"/>
-                </a:solidFill>
-              </a:rPr>
-              <a:t>Private subnet a</a:t>
-            </a:r>
-            <a:endParaRPr lang="en-US" sz="1400" dirty="0"/>
-          </a:p>
-          <a:p>
-            <a:pPr algn="ctr" indent="0" marL="0">
-              <a:buNone/>
-            </a:pPr>
-            <a:r>
-              <a:rPr lang="en-US" sz="1100" dirty="0">
-                <a:solidFill>
-                  <a:schemeClr val="tx2"/>
-                </a:solidFill>
-              </a:rPr>
-              <a:t>EKS managed nodes</a:t>
-            </a:r>
-            <a:endParaRPr lang="en-US" sz="1400" dirty="0"/>
-          </a:p>
-          <a:p>
-            <a:pPr algn="ctr" indent="0" marL="0">
-              <a:buNone/>
-            </a:pPr>
-            <a:r>
-              <a:rPr lang="en-US" sz="1100" dirty="0">
-                <a:solidFill>
-                  <a:schemeClr val="tx2"/>
-                </a:solidFill>
-              </a:rPr>
-              <a:t>(t3.medium, 2–4)</a:t>
-            </a:r>
-            <a:endParaRPr lang="en-US" sz="1400" dirty="0"/>
-          </a:p>
-        </p:txBody>
-      </p:sp>
-      <p:sp>
-        <p:nvSpPr>
-          <p:cNvPr id="12" name="Text 10"/>
+          <a:bodyPr wrap="square" lIns="0" tIns="0" rIns="0" bIns="0" rtlCol="0" anchor="t"/>
+          <a:lstStyle/>
+          <a:p>
+            <a:pPr indent="0" marL="0">
+              <a:buNone/>
+            </a:pPr>
+            <a:r>
+              <a:rPr lang="en-US" sz="2800" b="1" dirty="0">
+                <a:solidFill>
+                  <a:schemeClr val="accent1"/>
+                </a:solidFill>
+              </a:rPr>
+              <a:t>~40 s</a:t>
+            </a:r>
+            <a:endParaRPr lang="en-US" sz="2800" dirty="0"/>
+          </a:p>
+        </p:txBody>
+      </p:sp>
+      <p:sp>
+        <p:nvSpPr>
+          <p:cNvPr id="18" name="Text 16"/>
           <p:cNvSpPr txBox="1"/>
           <p:nvPr/>
         </p:nvSpPr>
         <p:spPr>
           <a:xfrm>
-            <a:off x="3931920" y="1874520"/>
-            <a:ext cx="2926080" cy="274320"/>
+            <a:off x="2377440" y="5989320"/>
+            <a:ext cx="1737360" cy="274320"/>
           </a:xfrm>
           <a:prstGeom prst="rect">
             <a:avLst/>
@@ -4606,54 +4800,27 @@
               <a:buNone/>
             </a:pPr>
             <a:r>
-              <a:rPr lang="en-US" sz="1100" b="1" dirty="0">
-                <a:solidFill>
-                  <a:schemeClr val="accent6"/>
-                </a:solidFill>
-              </a:rPr>
-              <a:t>AZ ap-south-1b</a:t>
-            </a:r>
-            <a:endParaRPr lang="en-US" sz="1100" dirty="0"/>
-          </a:p>
-        </p:txBody>
-      </p:sp>
-      <p:sp>
-        <p:nvSpPr>
-          <p:cNvPr id="13" name="box-Public subnet b"/>
-          <p:cNvSpPr/>
-          <p:nvPr/>
-        </p:nvSpPr>
-        <p:spPr>
-          <a:xfrm>
-            <a:off x="3931920" y="2194560"/>
-            <a:ext cx="2926080" cy="960120"/>
-          </a:xfrm>
-          <a:prstGeom prst="roundRect">
-            <a:avLst>
-              <a:gd name="adj" fmla="val 7619"/>
-            </a:avLst>
-          </a:prstGeom>
-          <a:solidFill>
-            <a:srgbClr val="E8F1EA"/>
-          </a:solidFill>
-          <a:ln w="12700">
-            <a:solidFill>
-              <a:srgbClr val="E8F1EA"/>
-            </a:solidFill>
-            <a:prstDash val="solid"/>
-          </a:ln>
-        </p:spPr>
-      </p:sp>
-      <p:sp>
-        <p:nvSpPr>
-          <p:cNvPr id="14" name="Text 12"/>
+              <a:rPr lang="en-US" sz="1200" dirty="0">
+                <a:solidFill>
+                  <a:schemeClr val="tx2"/>
+                </a:solidFill>
+              </a:rPr>
+              <a:t>apply on minikube</a:t>
+            </a:r>
+            <a:endParaRPr lang="en-US" sz="1200" dirty="0"/>
+          </a:p>
+        </p:txBody>
+      </p:sp>
+      <p:sp>
+        <p:nvSpPr>
+          <p:cNvPr id="19" name="Text 17"/>
           <p:cNvSpPr txBox="1"/>
           <p:nvPr/>
         </p:nvSpPr>
         <p:spPr>
           <a:xfrm>
-            <a:off x="3931920" y="2194560"/>
-            <a:ext cx="2926080" cy="960120"/>
+            <a:off x="4206240" y="5486400"/>
+            <a:ext cx="1737360" cy="502920"/>
           </a:xfrm>
           <a:prstGeom prst="rect">
             <a:avLst/>
@@ -4662,75 +4829,34 @@
           <a:ln/>
         </p:spPr>
         <p:txBody>
-          <a:bodyPr wrap="square" lIns="635" tIns="635" rIns="635" bIns="635" rtlCol="0" anchor="ctr"/>
-          <a:lstStyle/>
-          <a:p>
-            <a:pPr algn="ctr" indent="0" marL="0">
-              <a:buNone/>
-            </a:pPr>
-            <a:r>
-              <a:rPr lang="en-US" sz="1400" b="1" dirty="0">
-                <a:solidFill>
-                  <a:schemeClr val="tx1"/>
-                </a:solidFill>
-              </a:rPr>
-              <a:t>Public subnet b</a:t>
-            </a:r>
-            <a:endParaRPr lang="en-US" sz="1400" dirty="0"/>
-          </a:p>
-          <a:p>
-            <a:pPr algn="ctr" indent="0" marL="0">
-              <a:buNone/>
-            </a:pPr>
-            <a:r>
-              <a:rPr lang="en-US" sz="1100" dirty="0">
-                <a:solidFill>
-                  <a:schemeClr val="tx2"/>
-                </a:solidFill>
-              </a:rPr>
-              <a:t>load balancers</a:t>
-            </a:r>
-            <a:endParaRPr lang="en-US" sz="1400" dirty="0"/>
-          </a:p>
-        </p:txBody>
-      </p:sp>
-      <p:sp>
-        <p:nvSpPr>
-          <p:cNvPr id="15" name="box-Private subnet b"/>
-          <p:cNvSpPr/>
-          <p:nvPr/>
-        </p:nvSpPr>
-        <p:spPr>
-          <a:xfrm>
-            <a:off x="3931920" y="3337560"/>
-            <a:ext cx="2926080" cy="1234440"/>
-          </a:xfrm>
-          <a:prstGeom prst="roundRect">
-            <a:avLst>
-              <a:gd name="adj" fmla="val 5926"/>
-            </a:avLst>
-          </a:prstGeom>
-          <a:solidFill>
-            <a:srgbClr val="EEF0F5"/>
-          </a:solidFill>
-          <a:ln w="12700">
-            <a:solidFill>
-              <a:srgbClr val="EEF0F5"/>
-            </a:solidFill>
-            <a:prstDash val="solid"/>
-          </a:ln>
-        </p:spPr>
-      </p:sp>
-      <p:sp>
-        <p:nvSpPr>
-          <p:cNvPr id="16" name="Text 14"/>
+          <a:bodyPr wrap="square" lIns="0" tIns="0" rIns="0" bIns="0" rtlCol="0" anchor="t"/>
+          <a:lstStyle/>
+          <a:p>
+            <a:pPr indent="0" marL="0">
+              <a:buNone/>
+            </a:pPr>
+            <a:r>
+              <a:rPr lang="en-US" sz="2800" b="1" dirty="0">
+                <a:solidFill>
+                  <a:schemeClr val="accent2"/>
+                </a:solidFill>
+              </a:rPr>
+              <a:t>0</a:t>
+            </a:r>
+            <a:endParaRPr lang="en-US" sz="2800" dirty="0"/>
+          </a:p>
+        </p:txBody>
+      </p:sp>
+      <p:sp>
+        <p:nvSpPr>
+          <p:cNvPr id="20" name="Text 18"/>
           <p:cNvSpPr txBox="1"/>
           <p:nvPr/>
         </p:nvSpPr>
         <p:spPr>
           <a:xfrm>
-            <a:off x="3931920" y="3337560"/>
-            <a:ext cx="2926080" cy="1234440"/>
+            <a:off x="4206240" y="5989320"/>
+            <a:ext cx="1737360" cy="274320"/>
           </a:xfrm>
           <a:prstGeom prst="rect">
             <a:avLst/>
@@ -4739,132 +4865,27 @@
           <a:ln/>
         </p:spPr>
         <p:txBody>
-          <a:bodyPr wrap="square" lIns="635" tIns="635" rIns="635" bIns="635" rtlCol="0" anchor="ctr"/>
-          <a:lstStyle/>
-          <a:p>
-            <a:pPr algn="ctr" indent="0" marL="0">
-              <a:buNone/>
-            </a:pPr>
-            <a:r>
-              <a:rPr lang="en-US" sz="1400" b="1" dirty="0">
-                <a:solidFill>
-                  <a:schemeClr val="tx1"/>
-                </a:solidFill>
-              </a:rPr>
-              <a:t>Private subnet b</a:t>
-            </a:r>
-            <a:endParaRPr lang="en-US" sz="1400" dirty="0"/>
-          </a:p>
-          <a:p>
-            <a:pPr algn="ctr" indent="0" marL="0">
-              <a:buNone/>
-            </a:pPr>
-            <a:r>
-              <a:rPr lang="en-US" sz="1100" dirty="0">
+          <a:bodyPr wrap="square" lIns="0" tIns="0" rIns="0" bIns="0" rtlCol="0" anchor="t"/>
+          <a:lstStyle/>
+          <a:p>
+            <a:pPr indent="0" marL="0">
+              <a:buNone/>
+            </a:pPr>
+            <a:r>
+              <a:rPr lang="en-US" sz="1200" dirty="0">
                 <a:solidFill>
                   <a:schemeClr val="tx2"/>
                 </a:solidFill>
               </a:rPr>
-              <a:t>EKS managed nodes</a:t>
-            </a:r>
-            <a:endParaRPr lang="en-US" sz="1400" dirty="0"/>
-          </a:p>
-          <a:p>
-            <a:pPr algn="ctr" indent="0" marL="0">
-              <a:buNone/>
-            </a:pPr>
-            <a:r>
-              <a:rPr lang="en-US" sz="1100" dirty="0">
-                <a:solidFill>
-                  <a:schemeClr val="tx2"/>
-                </a:solidFill>
-              </a:rPr>
-              <a:t>(t3.medium, 2–4)</a:t>
-            </a:r>
-            <a:endParaRPr lang="en-US" sz="1400" dirty="0"/>
-          </a:p>
-        </p:txBody>
-      </p:sp>
-      <p:sp>
-        <p:nvSpPr>
-          <p:cNvPr id="17" name="box-EKS control plane 1.34"/>
-          <p:cNvSpPr/>
-          <p:nvPr/>
-        </p:nvSpPr>
-        <p:spPr>
-          <a:xfrm>
-            <a:off x="777240" y="4800600"/>
-            <a:ext cx="6080760" cy="1188720"/>
-          </a:xfrm>
-          <a:prstGeom prst="roundRect">
-            <a:avLst>
-              <a:gd name="adj" fmla="val 6154"/>
-            </a:avLst>
-          </a:prstGeom>
-          <a:solidFill>
-            <a:schemeClr val="tx1"/>
-          </a:solidFill>
-          <a:ln w="12700">
-            <a:solidFill>
-              <a:schemeClr val="tx1"/>
-            </a:solidFill>
-            <a:prstDash val="solid"/>
-          </a:ln>
-        </p:spPr>
-      </p:sp>
-      <p:sp>
-        <p:nvSpPr>
-          <p:cNvPr id="18" name="Text 16"/>
-          <p:cNvSpPr txBox="1"/>
-          <p:nvPr/>
-        </p:nvSpPr>
-        <p:spPr>
-          <a:xfrm>
-            <a:off x="777240" y="4800600"/>
-            <a:ext cx="6080760" cy="1188720"/>
-          </a:xfrm>
-          <a:prstGeom prst="rect">
-            <a:avLst/>
-          </a:prstGeom>
-          <a:noFill/>
-          <a:ln/>
-        </p:spPr>
-        <p:txBody>
-          <a:bodyPr wrap="square" lIns="635" tIns="635" rIns="635" bIns="635" rtlCol="0" anchor="ctr"/>
-          <a:lstStyle/>
-          <a:p>
-            <a:pPr algn="ctr" indent="0" marL="0">
-              <a:buNone/>
-            </a:pPr>
-            <a:r>
-              <a:rPr lang="en-US" sz="1400" b="1" dirty="0">
-                <a:solidFill>
-                  <a:schemeClr val="bg1"/>
-                </a:solidFill>
-              </a:rPr>
-              <a:t>EKS control plane 1.34</a:t>
-            </a:r>
-            <a:endParaRPr lang="en-US" sz="1400" dirty="0"/>
-          </a:p>
-          <a:p>
-            <a:pPr algn="ctr" indent="0" marL="0">
-              <a:buNone/>
-            </a:pPr>
-            <a:r>
-              <a:rPr lang="en-US" sz="1100" dirty="0">
-                <a:solidFill>
-                  <a:schemeClr val="bg2"/>
-                </a:solidFill>
-              </a:rPr>
-              <a:t>add-ons: vpc-cni · kube-proxy · coredns · pod-identity · metrics-server (HPA) · aws-ebs-csi-driver (Postgres PVC)</a:t>
-            </a:r>
-            <a:endParaRPr lang="en-US" sz="1400" dirty="0"/>
+              <a:t>left after destroy</a:t>
+            </a:r>
+            <a:endParaRPr lang="en-US" sz="1200" dirty="0"/>
           </a:p>
         </p:txBody>
       </p:sp>
       <p:pic>
         <p:nvPicPr>
-          <p:cNvPr id="19" name="img-22-terraform-validate.png" descr="22-terraform-validate.png">    </p:cNvPr>
+          <p:cNvPr id="21" name="img-22b-terraform-apply.png" descr="22b-terraform-apply.png">    </p:cNvPr>
           <p:cNvPicPr>
             <a:picLocks noChangeAspect="1"/>
           </p:cNvPicPr>
@@ -4878,8 +4899,8 @@
         </p:blipFill>
         <p:spPr>
           <a:xfrm>
-            <a:off x="7589520" y="1371600"/>
-            <a:ext cx="4050792" cy="1959383"/>
+            <a:off x="6355080" y="1325880"/>
+            <a:ext cx="5285232" cy="3789707"/>
           </a:xfrm>
           <a:prstGeom prst="rect">
             <a:avLst/>
@@ -4895,14 +4916,14 @@
       </p:pic>
       <p:sp>
         <p:nvSpPr>
-          <p:cNvPr id="20" name="Text 17"/>
+          <p:cNvPr id="22" name="Text 19"/>
           <p:cNvSpPr txBox="1"/>
           <p:nvPr/>
         </p:nvSpPr>
         <p:spPr>
           <a:xfrm>
-            <a:off x="7589520" y="3559583"/>
-            <a:ext cx="4050792" cy="1737360"/>
+            <a:off x="6355080" y="5207027"/>
+            <a:ext cx="5285232" cy="274320"/>
           </a:xfrm>
           <a:prstGeom prst="rect">
             <a:avLst/>
@@ -4914,94 +4935,18 @@
           <a:bodyPr wrap="square" lIns="0" tIns="0" rIns="0" bIns="0" rtlCol="0" anchor="t"/>
           <a:lstStyle/>
           <a:p>
-            <a:pPr marL="190500" indent="-190500">
-              <a:spcAft>
-                <a:spcPts val="700"/>
-              </a:spcAft>
-              <a:buSzPct val="100000"/>
-              <a:buChar char="•"/>
-            </a:pPr>
-            <a:r>
-              <a:rPr lang="en-US" sz="1300" dirty="0">
-                <a:solidFill>
-                  <a:schemeClr val="tx1"/>
-                </a:solidFill>
-              </a:rPr>
-              <a:t>Plain resources split by concern: vpc.tf, iam.tf, eks.tf</a:t>
-            </a:r>
-            <a:endParaRPr lang="en-US" sz="1300" dirty="0"/>
-          </a:p>
-          <a:p>
-            <a:pPr marL="190500" indent="-190500">
-              <a:spcAft>
-                <a:spcPts val="700"/>
-              </a:spcAft>
-              <a:buSzPct val="100000"/>
-              <a:buChar char="•"/>
-            </a:pPr>
-            <a:r>
-              <a:rPr lang="en-US" sz="1300" dirty="0">
-                <a:solidFill>
-                  <a:schemeClr val="tx1"/>
-                </a:solidFill>
-              </a:rPr>
-              <a:t>use_nat_gateway toggle: false + SPOT nodes is the cheapest demo</a:t>
-            </a:r>
-            <a:endParaRPr lang="en-US" sz="1300" dirty="0"/>
-          </a:p>
-          <a:p>
-            <a:pPr marL="190500" indent="-190500">
-              <a:spcAft>
-                <a:spcPts val="700"/>
-              </a:spcAft>
-              <a:buSzPct val="100000"/>
-              <a:buChar char="•"/>
-            </a:pPr>
-            <a:r>
-              <a:rPr lang="en-US" sz="1300" dirty="0">
-                <a:solidFill>
-                  <a:schemeClr val="tx1"/>
-                </a:solidFill>
-              </a:rPr>
-              <a:t>terraform.tfvars.example only; no keys in Git</a:t>
-            </a:r>
-            <a:endParaRPr lang="en-US" sz="1300" dirty="0"/>
-          </a:p>
-        </p:txBody>
-      </p:sp>
-      <p:sp>
-        <p:nvSpPr>
-          <p:cNvPr id="21" name="Text 18"/>
-          <p:cNvSpPr txBox="1"/>
-          <p:nvPr/>
-        </p:nvSpPr>
-        <p:spPr>
-          <a:xfrm>
-            <a:off x="7589520" y="5623560"/>
-            <a:ext cx="4050792" cy="594360"/>
-          </a:xfrm>
-          <a:prstGeom prst="rect">
-            <a:avLst/>
-          </a:prstGeom>
-          <a:noFill/>
-          <a:ln/>
-        </p:spPr>
-        <p:txBody>
-          <a:bodyPr wrap="square" lIns="0" tIns="0" rIns="0" bIns="0" rtlCol="0" anchor="t"/>
-          <a:lstStyle/>
-          <a:p>
             <a:pPr indent="0" marL="0">
               <a:buNone/>
             </a:pPr>
             <a:r>
-              <a:rPr lang="en-US" sz="1200" b="1" dirty="0">
-                <a:solidFill>
-                  <a:schemeClr val="accent3"/>
-                </a:solidFill>
-              </a:rPr>
-              <a:t>Status: fmt + validate pass. plan/apply need AWS credentials and have not been run yet.</a:t>
-            </a:r>
-            <a:endParaRPr lang="en-US" sz="1200" dirty="0"/>
+              <a:rPr lang="en-US" sz="1100" i="1" dirty="0">
+                <a:solidFill>
+                  <a:schemeClr val="accent6"/>
+                </a:solidFill>
+              </a:rPr>
+              <a:t>Real run on minikube; destroy then removed both namespaces and the Postgres volume</a:t>
+            </a:r>
+            <a:endParaRPr lang="en-US" sz="1100" dirty="0"/>
           </a:p>
         </p:txBody>
       </p:sp>
@@ -9599,10 +9544,10 @@
                       <a:r>
                         <a:rPr lang="en-US" sz="1400" b="1" dirty="0">
                           <a:solidFill>
-                            <a:schemeClr val="accent3"/>
+                            <a:schemeClr val="accent2"/>
                           </a:solidFill>
                         </a:rPr>
-                        <a:t>Next</a:t>
+                        <a:t>Done</a:t>
                       </a:r>
                       <a:endParaRPr lang="en-US" sz="1400" dirty="0"/>
                     </a:p>
@@ -9639,7 +9584,7 @@
                             <a:schemeClr val="tx1"/>
                           </a:solidFill>
                         </a:rPr>
-                        <a:t>GitHub Actions</a:t>
+                        <a:t>Terraform</a:t>
                       </a:r>
                       <a:endParaRPr lang="en-US" sz="1400" dirty="0"/>
                     </a:p>
@@ -9676,7 +9621,7 @@
                             <a:schemeClr val="tx1"/>
                           </a:solidFill>
                         </a:rPr>
-                        <a:t>actionlint clean; runs once the repo is pushed to GitHub</a:t>
+                        <a:t>plan / apply / destroy on minikube; destroy leaves nothing behind</a:t>
                       </a:r>
                       <a:endParaRPr lang="en-US" sz="1400" dirty="0"/>
                     </a:p>
@@ -9752,7 +9697,7 @@
                             <a:schemeClr val="tx1"/>
                           </a:solidFill>
                         </a:rPr>
-                        <a:t>Terraform on AWS</a:t>
+                        <a:t>GitHub Actions</a:t>
                       </a:r>
                       <a:endParaRPr lang="en-US" sz="1400" dirty="0"/>
                     </a:p>
@@ -9789,7 +9734,7 @@
                             <a:schemeClr val="tx1"/>
                           </a:solidFill>
                         </a:rPr>
-                        <a:t>validate passes; plan/apply need AWS credentials (then destroy)</a:t>
+                        <a:t>actionlint clean; runs once the repo is pushed to GitHub</a:t>
                       </a:r>
                       <a:endParaRPr lang="en-US" sz="1400" dirty="0"/>
                     </a:p>
@@ -9971,7 +9916,7 @@
         </p:nvSpPr>
         <p:spPr>
           <a:xfrm>
-            <a:off x="7040880" y="1234440"/>
+            <a:off x="7040880" y="914400"/>
             <a:ext cx="457200" cy="457200"/>
           </a:xfrm>
           <a:prstGeom prst="ellipse">
@@ -9996,7 +9941,7 @@
         </p:nvSpPr>
         <p:spPr>
           <a:xfrm>
-            <a:off x="7040880" y="1234440"/>
+            <a:off x="7040880" y="914400"/>
             <a:ext cx="457200" cy="457200"/>
           </a:xfrm>
           <a:prstGeom prst="rect">
@@ -10032,7 +9977,7 @@
         </p:nvSpPr>
         <p:spPr>
           <a:xfrm>
-            <a:off x="7680960" y="1216152"/>
+            <a:off x="7680960" y="896112"/>
             <a:ext cx="4023360" cy="502920"/>
           </a:xfrm>
           <a:prstGeom prst="rect">
@@ -10068,7 +10013,7 @@
         </p:nvSpPr>
         <p:spPr>
           <a:xfrm>
-            <a:off x="7040880" y="1947672"/>
+            <a:off x="7040880" y="1609344"/>
             <a:ext cx="457200" cy="457200"/>
           </a:xfrm>
           <a:prstGeom prst="ellipse">
@@ -10093,7 +10038,7 @@
         </p:nvSpPr>
         <p:spPr>
           <a:xfrm>
-            <a:off x="7040880" y="1947672"/>
+            <a:off x="7040880" y="1609344"/>
             <a:ext cx="457200" cy="457200"/>
           </a:xfrm>
           <a:prstGeom prst="rect">
@@ -10129,7 +10074,7 @@
         </p:nvSpPr>
         <p:spPr>
           <a:xfrm>
-            <a:off x="7680960" y="1929384"/>
+            <a:off x="7680960" y="1591056"/>
             <a:ext cx="4023360" cy="502920"/>
           </a:xfrm>
           <a:prstGeom prst="rect">
@@ -10165,7 +10110,7 @@
         </p:nvSpPr>
         <p:spPr>
           <a:xfrm>
-            <a:off x="7040880" y="2660904"/>
+            <a:off x="7040880" y="2304288"/>
             <a:ext cx="457200" cy="457200"/>
           </a:xfrm>
           <a:prstGeom prst="ellipse">
@@ -10190,7 +10135,7 @@
         </p:nvSpPr>
         <p:spPr>
           <a:xfrm>
-            <a:off x="7040880" y="2660904"/>
+            <a:off x="7040880" y="2304288"/>
             <a:ext cx="457200" cy="457200"/>
           </a:xfrm>
           <a:prstGeom prst="rect">
@@ -10226,7 +10171,7 @@
         </p:nvSpPr>
         <p:spPr>
           <a:xfrm>
-            <a:off x="7680960" y="2642616"/>
+            <a:off x="7680960" y="2286000"/>
             <a:ext cx="4023360" cy="502920"/>
           </a:xfrm>
           <a:prstGeom prst="rect">
@@ -10262,7 +10207,7 @@
         </p:nvSpPr>
         <p:spPr>
           <a:xfrm>
-            <a:off x="7040880" y="3374136"/>
+            <a:off x="7040880" y="2999232"/>
             <a:ext cx="457200" cy="457200"/>
           </a:xfrm>
           <a:prstGeom prst="ellipse">
@@ -10287,7 +10232,7 @@
         </p:nvSpPr>
         <p:spPr>
           <a:xfrm>
-            <a:off x="7040880" y="3374136"/>
+            <a:off x="7040880" y="2999232"/>
             <a:ext cx="457200" cy="457200"/>
           </a:xfrm>
           <a:prstGeom prst="rect">
@@ -10323,7 +10268,7 @@
         </p:nvSpPr>
         <p:spPr>
           <a:xfrm>
-            <a:off x="7680960" y="3355848"/>
+            <a:off x="7680960" y="2980944"/>
             <a:ext cx="4023360" cy="502920"/>
           </a:xfrm>
           <a:prstGeom prst="rect">
@@ -10345,7 +10290,7 @@
                   <a:schemeClr val="bg1"/>
                 </a:solidFill>
               </a:rPr>
-              <a:t>helm upgrade and a rolling update</a:t>
+              <a:t>terraform plan / apply / destroy</a:t>
             </a:r>
             <a:endParaRPr lang="en-US" sz="1600" dirty="0"/>
           </a:p>
@@ -10359,7 +10304,7 @@
         </p:nvSpPr>
         <p:spPr>
           <a:xfrm>
-            <a:off x="7040880" y="4087368"/>
+            <a:off x="7040880" y="3694176"/>
             <a:ext cx="457200" cy="457200"/>
           </a:xfrm>
           <a:prstGeom prst="ellipse">
@@ -10384,7 +10329,7 @@
         </p:nvSpPr>
         <p:spPr>
           <a:xfrm>
-            <a:off x="7040880" y="4087368"/>
+            <a:off x="7040880" y="3694176"/>
             <a:ext cx="457200" cy="457200"/>
           </a:xfrm>
           <a:prstGeom prst="rect">
@@ -10420,7 +10365,7 @@
         </p:nvSpPr>
         <p:spPr>
           <a:xfrm>
-            <a:off x="7680960" y="4069080"/>
+            <a:off x="7680960" y="3675888"/>
             <a:ext cx="4023360" cy="502920"/>
           </a:xfrm>
           <a:prstGeom prst="rect">
@@ -10442,7 +10387,7 @@
                   <a:schemeClr val="bg1"/>
                 </a:solidFill>
               </a:rPr>
-              <a:t>load-test.sh and the HPA scaling out</a:t>
+              <a:t>helm upgrade and a rolling update</a:t>
             </a:r>
             <a:endParaRPr lang="en-US" sz="1600" dirty="0"/>
           </a:p>
@@ -10456,7 +10401,7 @@
         </p:nvSpPr>
         <p:spPr>
           <a:xfrm>
-            <a:off x="7040880" y="4800600"/>
+            <a:off x="7040880" y="4389120"/>
             <a:ext cx="457200" cy="457200"/>
           </a:xfrm>
           <a:prstGeom prst="ellipse">
@@ -10481,7 +10426,7 @@
         </p:nvSpPr>
         <p:spPr>
           <a:xfrm>
-            <a:off x="7040880" y="4800600"/>
+            <a:off x="7040880" y="4389120"/>
             <a:ext cx="457200" cy="457200"/>
           </a:xfrm>
           <a:prstGeom prst="rect">
@@ -10517,7 +10462,7 @@
         </p:nvSpPr>
         <p:spPr>
           <a:xfrm>
-            <a:off x="7680960" y="4782312"/>
+            <a:off x="7680960" y="4370832"/>
             <a:ext cx="4023360" cy="502920"/>
           </a:xfrm>
           <a:prstGeom prst="rect">
@@ -10539,6 +10484,103 @@
                   <a:schemeClr val="bg1"/>
                 </a:solidFill>
               </a:rPr>
+              <a:t>load-test.sh and the HPA scaling out</a:t>
+            </a:r>
+            <a:endParaRPr lang="en-US" sz="1600" dirty="0"/>
+          </a:p>
+        </p:txBody>
+      </p:sp>
+      <p:sp>
+        <p:nvSpPr>
+          <p:cNvPr id="22" name="step"/>
+          <p:cNvSpPr/>
+          <p:nvPr/>
+        </p:nvSpPr>
+        <p:spPr>
+          <a:xfrm>
+            <a:off x="7040880" y="5084064"/>
+            <a:ext cx="457200" cy="457200"/>
+          </a:xfrm>
+          <a:prstGeom prst="ellipse">
+            <a:avLst/>
+          </a:prstGeom>
+          <a:solidFill>
+            <a:schemeClr val="accent1"/>
+          </a:solidFill>
+          <a:ln w="12700">
+            <a:solidFill>
+              <a:schemeClr val="accent1"/>
+            </a:solidFill>
+            <a:prstDash val="solid"/>
+          </a:ln>
+        </p:spPr>
+      </p:sp>
+      <p:sp>
+        <p:nvSpPr>
+          <p:cNvPr id="23" name="Text 21"/>
+          <p:cNvSpPr txBox="1"/>
+          <p:nvPr/>
+        </p:nvSpPr>
+        <p:spPr>
+          <a:xfrm>
+            <a:off x="7040880" y="5084064"/>
+            <a:ext cx="457200" cy="457200"/>
+          </a:xfrm>
+          <a:prstGeom prst="rect">
+            <a:avLst/>
+          </a:prstGeom>
+          <a:noFill/>
+          <a:ln/>
+        </p:spPr>
+        <p:txBody>
+          <a:bodyPr wrap="square" lIns="0" tIns="0" rIns="0" bIns="0" rtlCol="0" anchor="ctr"/>
+          <a:lstStyle/>
+          <a:p>
+            <a:pPr algn="ctr" indent="0" marL="0">
+              <a:buNone/>
+            </a:pPr>
+            <a:r>
+              <a:rPr lang="en-US" sz="1600" b="1" dirty="0">
+                <a:solidFill>
+                  <a:schemeClr val="bg1"/>
+                </a:solidFill>
+              </a:rPr>
+              <a:t>7</a:t>
+            </a:r>
+            <a:endParaRPr lang="en-US" sz="1600" dirty="0"/>
+          </a:p>
+        </p:txBody>
+      </p:sp>
+      <p:sp>
+        <p:nvSpPr>
+          <p:cNvPr id="24" name="Text 22"/>
+          <p:cNvSpPr txBox="1"/>
+          <p:nvPr/>
+        </p:nvSpPr>
+        <p:spPr>
+          <a:xfrm>
+            <a:off x="7680960" y="5065776"/>
+            <a:ext cx="4023360" cy="502920"/>
+          </a:xfrm>
+          <a:prstGeom prst="rect">
+            <a:avLst/>
+          </a:prstGeom>
+          <a:noFill/>
+          <a:ln/>
+        </p:spPr>
+        <p:txBody>
+          <a:bodyPr wrap="square" lIns="0" tIns="0" rIns="0" bIns="0" rtlCol="0" anchor="ctr"/>
+          <a:lstStyle/>
+          <a:p>
+            <a:pPr indent="0" marL="0">
+              <a:buNone/>
+            </a:pPr>
+            <a:r>
+              <a:rPr lang="en-US" sz="1600" dirty="0">
+                <a:solidFill>
+                  <a:schemeClr val="bg1"/>
+                </a:solidFill>
+              </a:rPr>
               <a:t>Grafana live, then a troubleshooting scenario</a:t>
             </a:r>
             <a:endParaRPr lang="en-US" sz="1600" dirty="0"/>
@@ -10547,7 +10589,7 @@
       </p:sp>
       <p:sp>
         <p:nvSpPr>
-          <p:cNvPr id="22" name="Text 20"/>
+          <p:cNvPr id="25" name="Text 23"/>
           <p:cNvSpPr txBox="1"/>
           <p:nvPr/>
         </p:nvSpPr>
@@ -11517,7 +11559,7 @@
                   <a:schemeClr val="tx2"/>
                 </a:solidFill>
               </a:rPr>
-              <a:t>AWS VPC + EKS</a:t>
+              <a:t>namespaces + Helm releases</a:t>
             </a:r>
             <a:endParaRPr lang="en-US" sz="1400" dirty="0"/>
           </a:p>
@@ -11628,7 +11670,7 @@
                   <a:schemeClr val="accent1"/>
                 </a:solidFill>
               </a:rPr>
-              <a:t>Kubernetes cluster  (minikube today · EKS via Terraform)</a:t>
+              <a:t>Kubernetes cluster  (minikube)</a:t>
             </a:r>
             <a:endParaRPr lang="en-US" sz="1200" dirty="0"/>
           </a:p>
@@ -11748,7 +11790,7 @@
                   <a:schemeClr val="accent6"/>
                 </a:solidFill>
               </a:rPr>
-              <a:t>provisions</a:t>
+              <a:t>applies</a:t>
             </a:r>
             <a:endParaRPr lang="en-US" sz="1000" dirty="0"/>
           </a:p>

</xml_diff>

<commit_message>
docs: recapture cluster screenshots and deck from the Terraform-managed deployment
</commit_message>
<xml_diff>
--- a/presentation/GearLoop-Capstone.pptx
+++ b/presentation/GearLoop-Capstone.pptx
@@ -125,44 +125,44 @@
   <p:extLst>
     <p:ext uri="{521415D9-36F7-43E2-AB2F-B90AF26B5E84}">
       <p14:sectionLst xmlns:p14="http://schemas.microsoft.com/office/powerpoint/2010/main">
-        <p14:section name="Introduction" id="{7d10cc29-a68f-8f9c-1c7e-557a60ad242a}">
+        <p14:section name="Introduction" id="{fa316438-f69d-9ca0-b400-6adae4879502}">
           <p14:sldIdLst>
             <p14:sldId id="256"/>
             <p14:sldId id="257"/>
           </p14:sldIdLst>
         </p14:section>
-        <p14:section name="Architecture" id="{c7e29be8-7d27-4978-9690-ee1e9bc3e117}">
+        <p14:section name="Architecture" id="{817c6bc3-2d24-5b21-19f4-46d7c9c5322d}">
           <p14:sldIdLst>
             <p14:sldId id="258"/>
           </p14:sldIdLst>
         </p14:section>
-        <p14:section name="Application" id="{31d3a430-385d-af87-06cb-b67a291dc646}">
+        <p14:section name="Application" id="{7abc5c05-2153-27fd-50b4-6d47dd9b94c3}">
           <p14:sldIdLst>
             <p14:sldId id="259"/>
             <p14:sldId id="260"/>
             <p14:sldId id="261"/>
           </p14:sldIdLst>
         </p14:section>
-        <p14:section name="Build and test" id="{843ef060-94b3-19da-809e-637a49631b0c}">
+        <p14:section name="Build and test" id="{4ae135fc-c009-ca04-6a98-4b20d296359e}">
           <p14:sldIdLst>
             <p14:sldId id="262"/>
             <p14:sldId id="263"/>
           </p14:sldIdLst>
         </p14:section>
-        <p14:section name="Delivery" id="{794ac28f-c567-8782-9b17-98965fa9bde5}">
+        <p14:section name="Delivery" id="{98f31a95-1a47-432d-2718-6f414345c800}">
           <p14:sldIdLst>
             <p14:sldId id="264"/>
             <p14:sldId id="265"/>
           </p14:sldIdLst>
         </p14:section>
-        <p14:section name="Infrastructure" id="{e8240235-eb07-31b6-be2e-18cf103ef7af}">
+        <p14:section name="Infrastructure" id="{1d6724a0-c0bb-f7df-dabb-10c7f564a7c0}">
           <p14:sldIdLst>
             <p14:sldId id="266"/>
             <p14:sldId id="267"/>
             <p14:sldId id="268"/>
           </p14:sldIdLst>
         </p14:section>
-        <p14:section name="Operate" id="{66cb701a-96cc-3b52-4c39-aee8ecf955b0}">
+        <p14:section name="Operate" id="{bc6e1598-0d3e-1b3c-2e2a-59a05d793579}">
           <p14:sldIdLst>
             <p14:sldId id="269"/>
             <p14:sldId id="270"/>
@@ -170,7 +170,7 @@
             <p14:sldId id="272"/>
           </p14:sldIdLst>
         </p14:section>
-        <p14:section name="Wrap-up" id="{4b5606fd-492f-68c5-e271-4a4c8b7cf305}">
+        <p14:section name="Wrap-up" id="{a2e6bc11-e18a-a9ed-8c69-abd4004aed36}">
           <p14:sldIdLst>
             <p14:sldId id="273"/>
             <p14:sldId id="274"/>
@@ -559,34 +559,34 @@
                   <c:v>2</c:v>
                 </c:pt>
                 <c:pt idx="5">
-                  <c:v>363</c:v>
+                  <c:v>438</c:v>
                 </c:pt>
                 <c:pt idx="6">
-                  <c:v>363</c:v>
+                  <c:v>438</c:v>
                 </c:pt>
                 <c:pt idx="7">
-                  <c:v>363</c:v>
+                  <c:v>438</c:v>
                 </c:pt>
                 <c:pt idx="8">
-                  <c:v>363</c:v>
+                  <c:v>438</c:v>
                 </c:pt>
                 <c:pt idx="9">
-                  <c:v>333</c:v>
+                  <c:v>348</c:v>
                 </c:pt>
                 <c:pt idx="10">
-                  <c:v>333</c:v>
+                  <c:v>348</c:v>
                 </c:pt>
                 <c:pt idx="11">
-                  <c:v>333</c:v>
+                  <c:v>348</c:v>
                 </c:pt>
                 <c:pt idx="12">
-                  <c:v>333</c:v>
+                  <c:v>348</c:v>
                 </c:pt>
                 <c:pt idx="13">
-                  <c:v>185</c:v>
+                  <c:v>170</c:v>
                 </c:pt>
                 <c:pt idx="14">
-                  <c:v>185</c:v>
+                  <c:v>170</c:v>
                 </c:pt>
               </c:numCache>
             </c:numRef>
@@ -778,7 +778,7 @@
         <c:axId val="2094734553"/>
         <c:scaling>
           <c:orientation val="minMax"/>
-          <c:max val="400"/>
+          <c:max val="500"/>
           <c:min val="0"/>
         </c:scaling>
         <c:delete val="0"/>
@@ -1588,7 +1588,7 @@
           <a:p>
             <a:r>
               <a:rPr lang="en-US" dirty="0"/>
-              <a:t>One Helm chart deploys everything. Five revisions so far, including a rolling restart of six pods with no downtime. helm test runs a smoke-test pod that checks the API, the UI and the UI-to-API proxy.</a:t>
+              <a:t>One Helm chart deploys everything, and Terraform installs it. Before switching to Terraform I also tested upgrades and a rolling restart of six pods with no downtime. helm test runs a smoke-test pod that checks the API, the UI and the UI-to-API proxy.</a:t>
             </a:r>
             <a:endParaRPr lang="en-US" dirty="0"/>
           </a:p>
@@ -1764,7 +1764,7 @@
           <a:p>
             <a:r>
               <a:rPr lang="en-US" dirty="0"/>
-              <a:t>These are the real samples from the load test I ran while making this deck. CPU jumped to more than six times the target, and the HPA doubled the deployment, then tripled it. Scale-down is deliberately slower, with a two-minute stabilisation window, so it does not flap.</a:t>
+              <a:t>These are the real samples from the load test I ran while making this deck. CPU jumped to more than seven times the target, and the HPA doubled the deployment, then tripled it. Scale-down is deliberately slower, with a two-minute stabilisation window, so it does not flap.</a:t>
             </a:r>
             <a:endParaRPr lang="en-US" dirty="0"/>
           </a:p>
@@ -1852,7 +1852,7 @@
           <a:p>
             <a:r>
               <a:rPr lang="en-US" dirty="0"/>
-              <a:t>The Grafana dashboard ships inside the Helm chart as a ConfigMap, so a fresh cluster gets it automatically. Besides HTTP traffic and latency it shows business data: how many items are on loan or overdue. During the load test the p95 latency alert went to pending, which shows the rules work.</a:t>
+              <a:t>The Grafana dashboard ships inside the Helm chart as a ConfigMap, so a fresh cluster gets it automatically. Besides HTTP traffic and latency it shows business data: how many items are on loan or overdue. All four alert rules are loaded; the overdue-equipment rule is pending because one item really is overdue.</a:t>
             </a:r>
             <a:endParaRPr lang="en-US" dirty="0"/>
           </a:p>
@@ -5075,7 +5075,7 @@
         <p:spPr>
           <a:xfrm>
             <a:off x="548640" y="1325880"/>
-            <a:ext cx="7040880" cy="3844090"/>
+            <a:ext cx="7040880" cy="3717013"/>
           </a:xfrm>
           <a:prstGeom prst="rect">
             <a:avLst/>
@@ -5097,7 +5097,7 @@
         </p:nvSpPr>
         <p:spPr>
           <a:xfrm>
-            <a:off x="548640" y="5352850"/>
+            <a:off x="548640" y="5225773"/>
             <a:ext cx="7040880" cy="365760"/>
           </a:xfrm>
           <a:prstGeom prst="rect">
@@ -5130,7 +5130,7 @@
                   <a:schemeClr val="tx1"/>
                 </a:solidFill>
               </a:rPr>
-              <a:t>5 revisions (install + 4 upgrades)   </a:t>
+              <a:t>rev 1, installed by terraform apply   </a:t>
             </a:r>
             <a:pPr indent="0" marL="0">
               <a:buNone/>
@@ -6591,7 +6591,7 @@
                   <a:schemeClr val="accent1"/>
                 </a:solidFill>
               </a:rPr>
-              <a:t>363 %</a:t>
+              <a:t>438 %</a:t>
             </a:r>
             <a:endParaRPr lang="en-US" sz="4000" dirty="0"/>
           </a:p>
@@ -9282,7 +9282,7 @@
                             <a:schemeClr val="tx1"/>
                           </a:solidFill>
                         </a:rPr>
-                        <a:t>install, 5 revisions, rolling restart, helm test passing</a:t>
+                        <a:t>installed by Terraform; upgrades + rolling restart tested; helm test passing</a:t>
                       </a:r>
                       <a:endParaRPr lang="en-US" sz="1400" dirty="0"/>
                     </a:p>

</xml_diff>